<commit_message>
docs: update official presentation Ariadne_Team_Aftermath_Submission.pptx with latest revision
</commit_message>
<xml_diff>
--- a/Ariadne_Team_Aftermath_Submission.pptx
+++ b/Ariadne_Team_Aftermath_Submission.pptx
@@ -266,7 +266,7 @@
 <file path=ppt/revisionInfo.xml><?xml version="1.0" encoding="utf-8"?>
 <p1510:revInfo xmlns:a="http://schemas.openxmlformats.org/drawingml/2006/main" xmlns:r="http://schemas.openxmlformats.org/officeDocument/2006/relationships" xmlns:p1510="http://schemas.microsoft.com/office/powerpoint/2015/10/main">
   <p1510:revLst>
-    <p1510:client id="{91E76DD7-3474-45A7-A7C7-ADCAF25B8DF7}" v="5" dt="2026-09-30T17:07:04.631"/>
+    <p1510:client id="{91E76DD7-3474-45A7-A7C7-ADCAF25B8DF7}" v="6" dt="2026-09-30T18:27:41.637"/>
   </p1510:revLst>
 </p1510:revInfo>
 </file>
@@ -276,7 +276,7 @@
   <pc:docChgLst>
     <pc:chgData name="ABHILASH SINGH" userId="1184774f3f6ffd68" providerId="LiveId" clId="{8C64058F-4A53-4092-95DD-1D1C9476134E}"/>
     <pc:docChg chg="undo redo custSel modSld">
-      <pc:chgData name="ABHILASH SINGH" userId="1184774f3f6ffd68" providerId="LiveId" clId="{8C64058F-4A53-4092-95DD-1D1C9476134E}" dt="2026-09-30T17:06:31.713" v="162" actId="20577"/>
+      <pc:chgData name="ABHILASH SINGH" userId="1184774f3f6ffd68" providerId="LiveId" clId="{8C64058F-4A53-4092-95DD-1D1C9476134E}" dt="2026-09-30T18:28:19.298" v="163" actId="20577"/>
       <pc:docMkLst>
         <pc:docMk/>
       </pc:docMkLst>
@@ -556,7 +556,7 @@
         </pc:spChg>
       </pc:sldChg>
       <pc:sldChg chg="delSp modSp mod">
-        <pc:chgData name="ABHILASH SINGH" userId="1184774f3f6ffd68" providerId="LiveId" clId="{8C64058F-4A53-4092-95DD-1D1C9476134E}" dt="2026-09-30T17:06:31.713" v="162" actId="20577"/>
+        <pc:chgData name="ABHILASH SINGH" userId="1184774f3f6ffd68" providerId="LiveId" clId="{8C64058F-4A53-4092-95DD-1D1C9476134E}" dt="2026-09-30T18:28:19.298" v="163" actId="20577"/>
         <pc:sldMkLst>
           <pc:docMk/>
           <pc:sldMk cId="0" sldId="266"/>
@@ -570,7 +570,7 @@
           </ac:spMkLst>
         </pc:spChg>
         <pc:spChg chg="mod">
-          <ac:chgData name="ABHILASH SINGH" userId="1184774f3f6ffd68" providerId="LiveId" clId="{8C64058F-4A53-4092-95DD-1D1C9476134E}" dt="2026-09-30T17:06:31.713" v="162" actId="20577"/>
+          <ac:chgData name="ABHILASH SINGH" userId="1184774f3f6ffd68" providerId="LiveId" clId="{8C64058F-4A53-4092-95DD-1D1C9476134E}" dt="2026-09-30T18:28:19.298" v="163" actId="20577"/>
           <ac:spMkLst>
             <pc:docMk/>
             <pc:sldMk cId="0" sldId="266"/>
@@ -15675,8 +15675,8 @@
         </p:nvSpPr>
         <p:spPr>
           <a:xfrm>
-            <a:off x="9253164" y="4544568"/>
-            <a:ext cx="530916" cy="269304"/>
+            <a:off x="9381406" y="4544568"/>
+            <a:ext cx="402674" cy="446276"/>
           </a:xfrm>
           <a:prstGeom prst="rect">
             <a:avLst/>
@@ -15700,14 +15700,34 @@
               <a:t>[</a:t>
             </a:r>
             <a:r>
-              <a:rPr lang="en-IN" sz="1150" b="1" dirty="0">
+              <a:rPr lang="en-IN" sz="1150" b="1" dirty="0" err="1">
                 <a:solidFill>
                   <a:srgbClr val="5C5E70"/>
                 </a:solidFill>
                 <a:latin typeface="Aptos"/>
                 <a:hlinkClick r:id="rId3"/>
               </a:rPr>
-              <a:t>link</a:t>
+              <a:t>lin</a:t>
+            </a:r>
+            <a:endParaRPr lang="en-IN" sz="1150" b="1">
+              <a:solidFill>
+                <a:srgbClr val="5C5E70"/>
+              </a:solidFill>
+              <a:latin typeface="Aptos"/>
+              <a:hlinkClick r:id="rId3"/>
+            </a:endParaRPr>
+          </a:p>
+          <a:p>
+            <a:pPr algn="r"/>
+            <a:r>
+              <a:rPr lang="en-IN" sz="1150" b="1">
+                <a:solidFill>
+                  <a:srgbClr val="5C5E70"/>
+                </a:solidFill>
+                <a:latin typeface="Aptos"/>
+                <a:hlinkClick r:id="rId3"/>
+              </a:rPr>
+              <a:t>k</a:t>
             </a:r>
             <a:r>
               <a:rPr sz="1150" b="1" dirty="0">

</xml_diff>